<commit_message>
Presentation finale du Demo Day et video de demonstration
La premiere slide mentionne la formation Angular Talent Lab d'Orange
Digital Center ; transitions par poussee entre les slides.

ChatDocs_OHADA_demo.mp4 : 30 secondes montees a partir de captures de
l'application en ligne, pour le plan B si la connexion tombe.

Co-Authored-By: Claude Opus 5.5 <noreply@anthropic.com>
</commit_message>
<xml_diff>
--- a/DemoDay_Groupe6.pptx
+++ b/DemoDay_Groupe6.pptx
@@ -876,7 +876,7 @@
             <a:r>
               <a:rPr lang="en-US" dirty="0"/>
               <a:t>FIDÈLE — 0:50 (fin à 6:30)
-Angular 18 → API Python FastAPI → PostgreSQL + pgvector (recherche par le sens).
+Angular 22 → API Python FastAPI → PostgreSQL + pgvector (recherche par le sens).
 Gemini transforme la question en vecteur ; Claude rédige à partir des seuls articles retrouvés.
 Hébergé sur Render : une API Python avec base vectorielle a besoin d'un serveur permanent (d'où pas Vercel).
 Plus de 520 tests automatisés : jamais un article cité qui n'ait été fourni.
@@ -1388,7 +1388,7 @@
           </a:prstGeom>
           <a:extLst>
             <a:ext uri="{C572A759-6A51-4108-AA02-DFA0A04FC94B}">
-              <ma14:wrappingTextBoxFlag xmlns:ma14="http://schemas.microsoft.com/office/mac/drawingml/2011/main" xmlns="" val="0"/>
+              <ma14:wrappingTextBoxFlag xmlns="" xmlns:ma14="http://schemas.microsoft.com/office/mac/drawingml/2011/main" val="0"/>
             </a:ext>
           </a:extLst>
         </p:spPr>
@@ -1463,7 +1463,7 @@
           </a:prstGeom>
           <a:extLst>
             <a:ext uri="{C572A759-6A51-4108-AA02-DFA0A04FC94B}">
-              <ma14:wrappingTextBoxFlag xmlns:ma14="http://schemas.microsoft.com/office/mac/drawingml/2011/main" xmlns="" val="0"/>
+              <ma14:wrappingTextBoxFlag xmlns="" xmlns:ma14="http://schemas.microsoft.com/office/mac/drawingml/2011/main" val="0"/>
             </a:ext>
           </a:extLst>
         </p:spPr>
@@ -1812,6 +1812,10 @@
           </a:solidFill>
           <a:ln/>
         </p:spPr>
+        <p:txBody>
+          <a:bodyPr/>
+          <a:p/>
+        </p:txBody>
       </p:sp>
       <p:pic>
         <p:nvPicPr>
@@ -1925,7 +1929,7 @@
         <p:spPr>
           <a:xfrm>
             <a:off x="731520" y="4846320"/>
-            <a:ext cx="6035040" cy="1280160"/>
+            <a:ext cx="6035040" cy="868680"/>
           </a:xfrm>
           <a:prstGeom prst="rect">
             <a:avLst/>
@@ -1963,6 +1967,57 @@
               <a:t>Bitep Christian  ·  Diloua Angel  ·  Elock Fidèle</a:t>
             </a:r>
             <a:endParaRPr lang="en-US" sz="2400" dirty="0"/>
+          </a:p>
+        </p:txBody>
+      </p:sp>
+      <p:sp>
+        <p:nvSpPr>
+          <p:cNvPr id="20" name="Mention ODC"/>
+          <p:cNvSpPr txBox="1"/>
+          <p:nvPr/>
+        </p:nvSpPr>
+        <p:spPr>
+          <a:xfrm>
+            <a:off x="731520" y="5852160"/>
+            <a:ext cx="10698480" cy="777240"/>
+          </a:xfrm>
+          <a:prstGeom prst="rect">
+            <a:avLst/>
+          </a:prstGeom>
+          <a:noFill/>
+        </p:spPr>
+        <p:txBody>
+          <a:bodyPr wrap="square" lIns="0" rIns="0" tIns="0" bIns="0">
+            <a:spAutoFit/>
+          </a:bodyPr>
+          <a:lstStyle/>
+          <a:p>
+            <a:r>
+              <a:rPr sz="2400" b="0">
+                <a:solidFill>
+                  <a:srgbClr val="EEF1F7"/>
+                </a:solidFill>
+              </a:rPr>
+              <a:t>Projet réalisé dans le cadre de la formation </a:t>
+            </a:r>
+            <a:r>
+              <a:rPr sz="2400" b="1">
+                <a:solidFill>
+                  <a:srgbClr val="C9A227"/>
+                </a:solidFill>
+              </a:rPr>
+              <a:t>Angular Talent Lab</a:t>
+            </a:r>
+          </a:p>
+          <a:p>
+            <a:r>
+              <a:rPr sz="2400" b="1">
+                <a:solidFill>
+                  <a:srgbClr val="EEF1F7"/>
+                </a:solidFill>
+              </a:rPr>
+              <a:t>Orange Digital Center (ODC)</a:t>
+            </a:r>
           </a:p>
         </p:txBody>
       </p:sp>
@@ -2389,7 +2444,7 @@
     <a:masterClrMapping/>
   </p:clrMapOvr>
   <p:transition spd="med">
-    <p:push dir="l"/>
+    <p:push/>
   </p:transition>
 </p:sld>
 </file>
@@ -2924,7 +2979,7 @@
           </a:prstGeom>
           <a:extLst>
             <a:ext uri="{C572A759-6A51-4108-AA02-DFA0A04FC94B}">
-              <ma14:wrappingTextBoxFlag xmlns:ma14="http://schemas.microsoft.com/office/mac/drawingml/2011/main" xmlns="" val="0"/>
+              <ma14:wrappingTextBoxFlag xmlns="" xmlns:ma14="http://schemas.microsoft.com/office/mac/drawingml/2011/main" val="0"/>
             </a:ext>
           </a:extLst>
         </p:spPr>
@@ -2955,7 +3010,7 @@
     <a:masterClrMapping/>
   </p:clrMapOvr>
   <p:transition spd="med">
-    <p:push dir="l"/>
+    <p:push/>
   </p:transition>
 </p:sld>
 </file>
@@ -3101,7 +3156,7 @@
     <a:masterClrMapping/>
   </p:clrMapOvr>
   <p:transition spd="med">
-    <p:push dir="l"/>
+    <p:push/>
   </p:transition>
 </p:sld>
 </file>
@@ -3514,7 +3569,7 @@
           </a:prstGeom>
           <a:extLst>
             <a:ext uri="{C572A759-6A51-4108-AA02-DFA0A04FC94B}">
-              <ma14:wrappingTextBoxFlag xmlns:ma14="http://schemas.microsoft.com/office/mac/drawingml/2011/main" xmlns="" val="0"/>
+              <ma14:wrappingTextBoxFlag xmlns="" xmlns:ma14="http://schemas.microsoft.com/office/mac/drawingml/2011/main" val="0"/>
             </a:ext>
           </a:extLst>
         </p:spPr>
@@ -3545,7 +3600,7 @@
     <a:masterClrMapping/>
   </p:clrMapOvr>
   <p:transition spd="med">
-    <p:push dir="l"/>
+    <p:push/>
   </p:transition>
 </p:sld>
 </file>
@@ -3835,7 +3890,7 @@
           </a:prstGeom>
           <a:extLst>
             <a:ext uri="{C572A759-6A51-4108-AA02-DFA0A04FC94B}">
-              <ma14:wrappingTextBoxFlag xmlns:ma14="http://schemas.microsoft.com/office/mac/drawingml/2011/main" xmlns="" val="0"/>
+              <ma14:wrappingTextBoxFlag xmlns="" xmlns:ma14="http://schemas.microsoft.com/office/mac/drawingml/2011/main" val="0"/>
             </a:ext>
           </a:extLst>
         </p:spPr>
@@ -3866,7 +3921,7 @@
     <a:masterClrMapping/>
   </p:clrMapOvr>
   <p:transition spd="med">
-    <p:push dir="l"/>
+    <p:push/>
   </p:transition>
 </p:sld>
 </file>
@@ -3933,7 +3988,7 @@
       </p:sp>
       <p:sp>
         <p:nvSpPr>
-          <p:cNvPr id="3" name="Angular 18 — pastille"/>
+          <p:cNvPr id="3" name="Angular 22 — pastille"/>
           <p:cNvSpPr/>
           <p:nvPr/>
         </p:nvSpPr>
@@ -3953,7 +4008,7 @@
       </p:sp>
       <p:pic>
         <p:nvPicPr>
-          <p:cNvPr id="4" name="Angular 18 — icône" descr="preencoded.png"/>
+          <p:cNvPr id="4" name="Angular 22 — icône" descr="preencoded.png"/>
           <p:cNvPicPr>
             <a:picLocks noChangeAspect="1"/>
           </p:cNvPicPr>
@@ -4005,7 +4060,7 @@
                   <a:schemeClr val="tx2"/>
                 </a:solidFill>
               </a:rPr>
-              <a:t>Angular 18</a:t>
+              <a:t>Angular 22</a:t>
             </a:r>
             <a:endParaRPr lang="en-US" sz="2400" dirty="0"/>
           </a:p>
@@ -4547,7 +4602,7 @@
           </a:prstGeom>
           <a:extLst>
             <a:ext uri="{C572A759-6A51-4108-AA02-DFA0A04FC94B}">
-              <ma14:wrappingTextBoxFlag xmlns:ma14="http://schemas.microsoft.com/office/mac/drawingml/2011/main" xmlns="" val="0"/>
+              <ma14:wrappingTextBoxFlag xmlns="" xmlns:ma14="http://schemas.microsoft.com/office/mac/drawingml/2011/main" val="0"/>
             </a:ext>
           </a:extLst>
         </p:spPr>
@@ -4578,7 +4633,7 @@
     <a:masterClrMapping/>
   </p:clrMapOvr>
   <p:transition spd="med">
-    <p:push dir="l"/>
+    <p:push/>
   </p:transition>
 </p:sld>
 </file>
@@ -5077,7 +5132,7 @@
           </a:prstGeom>
           <a:extLst>
             <a:ext uri="{C572A759-6A51-4108-AA02-DFA0A04FC94B}">
-              <ma14:wrappingTextBoxFlag xmlns:ma14="http://schemas.microsoft.com/office/mac/drawingml/2011/main" xmlns="" val="0"/>
+              <ma14:wrappingTextBoxFlag xmlns="" xmlns:ma14="http://schemas.microsoft.com/office/mac/drawingml/2011/main" val="0"/>
             </a:ext>
           </a:extLst>
         </p:spPr>
@@ -5108,7 +5163,7 @@
     <a:masterClrMapping/>
   </p:clrMapOvr>
   <p:transition spd="med">
-    <p:push dir="l"/>
+    <p:push/>
   </p:transition>
 </p:sld>
 </file>
@@ -5601,7 +5656,7 @@
           </a:prstGeom>
           <a:extLst>
             <a:ext uri="{C572A759-6A51-4108-AA02-DFA0A04FC94B}">
-              <ma14:wrappingTextBoxFlag xmlns:ma14="http://schemas.microsoft.com/office/mac/drawingml/2011/main" xmlns="" val="0"/>
+              <ma14:wrappingTextBoxFlag xmlns="" xmlns:ma14="http://schemas.microsoft.com/office/mac/drawingml/2011/main" val="0"/>
             </a:ext>
           </a:extLst>
         </p:spPr>
@@ -5632,7 +5687,7 @@
     <a:masterClrMapping/>
   </p:clrMapOvr>
   <p:transition spd="med">
-    <p:push dir="l"/>
+    <p:push/>
   </p:transition>
 </p:sld>
 </file>
@@ -6125,7 +6180,7 @@
           </a:prstGeom>
           <a:extLst>
             <a:ext uri="{C572A759-6A51-4108-AA02-DFA0A04FC94B}">
-              <ma14:wrappingTextBoxFlag xmlns:ma14="http://schemas.microsoft.com/office/mac/drawingml/2011/main" xmlns="" val="0"/>
+              <ma14:wrappingTextBoxFlag xmlns="" xmlns:ma14="http://schemas.microsoft.com/office/mac/drawingml/2011/main" val="0"/>
             </a:ext>
           </a:extLst>
         </p:spPr>
@@ -6156,7 +6211,7 @@
     <a:masterClrMapping/>
   </p:clrMapOvr>
   <p:transition spd="med">
-    <p:push dir="l"/>
+    <p:push/>
   </p:transition>
 </p:sld>
 </file>

</xml_diff>